<commit_message>
Redesign EDA 06/07 charts for deck cohesion and clarity
Recolor the income blind-spot matrix and replace the CV driver model's
incremental-bar/residual chart with a single R2 waterfall, matching the
biweekly deck's brand palette. Append matching EDA 06/07 backup slides
to the docs deck. Round 2: simplify the waterfall further (drop the
population-vs-CV panel), bulletize backup-slide callouts, and remove
em dashes from deck copy.

Co-Authored-By: Claude Sonnet 5 <noreply@anthropic.com>
</commit_message>
<xml_diff>
--- a/docs/biweekly-2026-07-22.pptx
+++ b/docs/biweekly-2026-07-22.pptx
@@ -14,6 +14,8 @@
     <p:sldId id="262" r:id="rId8"/>
     <p:sldId id="263" r:id="rId9"/>
     <p:sldId id="264" r:id="rId10"/>
+    <p:sldId id="265" r:id="rId16"/>
+    <p:sldId id="266" r:id="rId17"/>
   </p:sldIdLst>
   <p:notesMasterIdLst>
     <p:notesMasterId r:id="rId11"/>
@@ -545,6 +547,146 @@
         <p14:creationId xmlns:p14="http://schemas.microsoft.com/office/powerpoint/2010/main" val="1024086991"/>
       </p:ext>
     </p:extLst>
+  </p:cSld>
+  <p:clrMapOvr>
+    <a:masterClrMapping/>
+  </p:clrMapOvr>
+</p:notes>
+</file>
+
+<file path=ppt/notesSlides/notesSlide10.xml><?xml version="1.0" encoding="utf-8"?>
+<p:notes xmlns:a="http://schemas.openxmlformats.org/drawingml/2006/main" xmlns:p="http://schemas.openxmlformats.org/presentationml/2006/main" xmlns:r="http://schemas.openxmlformats.org/officeDocument/2006/relationships">
+  <p:cSld>
+    <p:spTree>
+      <p:nvGrpSpPr>
+        <p:cNvPr id="1" name=""/>
+        <p:cNvGrpSpPr/>
+        <p:nvPr/>
+      </p:nvGrpSpPr>
+      <p:grpSpPr>
+        <a:xfrm>
+          <a:off x="0" y="0"/>
+          <a:ext cx="0" cy="0"/>
+          <a:chOff x="0" y="0"/>
+          <a:chExt cx="0" cy="0"/>
+        </a:xfrm>
+      </p:grpSpPr>
+      <p:sp>
+        <p:nvSpPr>
+          <p:cNvPr id="2" name="Slide Image Placeholder 1"/>
+          <p:cNvSpPr>
+            <a:spLocks noGrp="1"/>
+          </p:cNvSpPr>
+          <p:nvPr>
+            <p:ph type="sldImg" idx="2"/>
+          </p:nvPr>
+        </p:nvSpPr>
+        <p:spPr/>
+      </p:sp>
+      <p:sp>
+        <p:nvSpPr>
+          <p:cNvPr id="3" name="Notes Placeholder 2"/>
+          <p:cNvSpPr>
+            <a:spLocks noGrp="1"/>
+          </p:cNvSpPr>
+          <p:nvPr>
+            <p:ph type="body" idx="3" sz="quarter"/>
+          </p:nvPr>
+        </p:nvSpPr>
+        <p:spPr/>
+        <p:txBody>
+          <a:bodyPr/>
+          <a:lstStyle/>
+          <a:p>
+            <a:r>
+              <a:t>EDA 06 blind-spot matrix. Blind spot = 481/2,109 classified tracts (22.8%), the visually dominant gold quadrant with an on-chart callout. Equal-weight vs worst-component agree on only 84.6% of top-risk-quartile membership, so combination rules matter: do not claim locked tiers. Poverty/Black 65+ are labeled robustness cases only. No DHC privacy join into ACS rows.</a:t>
+            </a:r>
+          </a:p>
+        </p:txBody>
+      </p:sp>
+      <p:sp>
+        <p:nvSpPr>
+          <p:cNvPr id="4" name="Slide Number Placeholder 3"/>
+          <p:cNvSpPr>
+            <a:spLocks noGrp="1"/>
+          </p:cNvSpPr>
+          <p:nvPr>
+            <p:ph type="sldNum" idx="5" sz="quarter"/>
+          </p:nvPr>
+        </p:nvSpPr>
+        <p:spPr/>
+      </p:sp>
+    </p:spTree>
+  </p:cSld>
+  <p:clrMapOvr>
+    <a:masterClrMapping/>
+  </p:clrMapOvr>
+</p:notes>
+</file>
+
+<file path=ppt/notesSlides/notesSlide11.xml><?xml version="1.0" encoding="utf-8"?>
+<p:notes xmlns:a="http://schemas.openxmlformats.org/drawingml/2006/main" xmlns:p="http://schemas.openxmlformats.org/presentationml/2006/main" xmlns:r="http://schemas.openxmlformats.org/officeDocument/2006/relationships">
+  <p:cSld>
+    <p:spTree>
+      <p:nvGrpSpPr>
+        <p:cNvPr id="1" name=""/>
+        <p:cNvGrpSpPr/>
+        <p:nvPr/>
+      </p:nvGrpSpPr>
+      <p:grpSpPr>
+        <a:xfrm>
+          <a:off x="0" y="0"/>
+          <a:ext cx="0" cy="0"/>
+          <a:chOff x="0" y="0"/>
+          <a:chExt cx="0" cy="0"/>
+        </a:xfrm>
+      </p:grpSpPr>
+      <p:sp>
+        <p:nvSpPr>
+          <p:cNvPr id="2" name="Slide Image Placeholder 1"/>
+          <p:cNvSpPr>
+            <a:spLocks noGrp="1"/>
+          </p:cNvSpPr>
+          <p:nvPr>
+            <p:ph type="sldImg" idx="2"/>
+          </p:nvPr>
+        </p:nvSpPr>
+        <p:spPr/>
+      </p:sp>
+      <p:sp>
+        <p:nvSpPr>
+          <p:cNvPr id="3" name="Notes Placeholder 2"/>
+          <p:cNvSpPr>
+            <a:spLocks noGrp="1"/>
+          </p:cNvSpPr>
+          <p:nvPr>
+            <p:ph type="body" idx="3" sz="quarter"/>
+          </p:nvPr>
+        </p:nvSpPr>
+        <p:spPr/>
+        <p:txBody>
+          <a:bodyPr/>
+          <a:lstStyle/>
+          <a:p>
+            <a:r>
+              <a:t>EDA 07 resolves the JL Final Takeaway: place pop is not the CV driver, estimate size is. Chart is now a single R2 waterfall labeled by variable added; dropped the population-vs-CV scatter panel per lead feedback since it wasn't adding insight beyond the waterfall. Matched-size panel (if asked): Black 65+ is still noisier than population at similar counts (about 0.28 vs 0.17 median CV). Composite V2's optional cv_residual_high flag is a seed for counts, not a locked score component.</a:t>
+            </a:r>
+          </a:p>
+        </p:txBody>
+      </p:sp>
+      <p:sp>
+        <p:nvSpPr>
+          <p:cNvPr id="4" name="Slide Number Placeholder 3"/>
+          <p:cNvSpPr>
+            <a:spLocks noGrp="1"/>
+          </p:cNvSpPr>
+          <p:nvPr>
+            <p:ph type="sldNum" idx="5" sz="quarter"/>
+          </p:nvPr>
+        </p:nvSpPr>
+        <p:spPr/>
+      </p:sp>
+    </p:spTree>
   </p:cSld>
   <p:clrMapOvr>
     <a:masterClrMapping/>
@@ -1796,6 +1938,510 @@
 </p:sld>
 </file>
 
+<file path=ppt/slides/slide10.xml><?xml version="1.0" encoding="utf-8"?>
+<p:sld xmlns:a="http://schemas.openxmlformats.org/drawingml/2006/main" xmlns:p="http://schemas.openxmlformats.org/presentationml/2006/main" xmlns:r="http://schemas.openxmlformats.org/officeDocument/2006/relationships">
+  <p:cSld>
+    <p:spTree>
+      <p:nvGrpSpPr>
+        <p:cNvPr id="1" name=""/>
+        <p:cNvGrpSpPr/>
+        <p:nvPr/>
+      </p:nvGrpSpPr>
+      <p:grpSpPr/>
+      <p:sp>
+        <p:nvSpPr>
+          <p:cNvPr id="2" name="TextBox 1"/>
+          <p:cNvSpPr txBox="1"/>
+          <p:nvPr/>
+        </p:nvSpPr>
+        <p:spPr>
+          <a:xfrm>
+            <a:off x="548640" y="384048"/>
+            <a:ext cx="11064240" cy="292608"/>
+          </a:xfrm>
+          <a:prstGeom prst="rect">
+            <a:avLst/>
+          </a:prstGeom>
+          <a:noFill/>
+        </p:spPr>
+        <p:txBody>
+          <a:bodyPr wrap="square">
+            <a:spAutoFit/>
+          </a:bodyPr>
+          <a:lstStyle/>
+          <a:p>
+            <a:r>
+              <a:rPr sz="1050" b="1">
+                <a:solidFill>
+                  <a:srgbClr val="5A6B85"/>
+                </a:solidFill>
+                <a:latin typeface="Calibri"/>
+              </a:rPr>
+              <a:t>BACKUP  ·  COMPOSITE PROTOTYPE (EDA 06)</a:t>
+            </a:r>
+          </a:p>
+        </p:txBody>
+      </p:sp>
+      <p:sp>
+        <p:nvSpPr>
+          <p:cNvPr id="3" name="TextBox 2"/>
+          <p:cNvSpPr txBox="1"/>
+          <p:nvPr/>
+        </p:nvSpPr>
+        <p:spPr>
+          <a:xfrm>
+            <a:off x="548640" y="658368"/>
+            <a:ext cx="11064240" cy="566928"/>
+          </a:xfrm>
+          <a:prstGeom prst="rect">
+            <a:avLst/>
+          </a:prstGeom>
+          <a:noFill/>
+        </p:spPr>
+        <p:txBody>
+          <a:bodyPr wrap="square">
+            <a:spAutoFit/>
+          </a:bodyPr>
+          <a:lstStyle/>
+          <a:p>
+            <a:r>
+              <a:rPr sz="2400" b="0">
+                <a:solidFill>
+                  <a:srgbClr val="1E2761"/>
+                </a:solidFill>
+                <a:latin typeface="Calibri Light"/>
+              </a:rPr>
+              <a:t>The CV-only blind spot: ~23% of tracts</a:t>
+            </a:r>
+          </a:p>
+        </p:txBody>
+      </p:sp>
+      <p:sp>
+        <p:nvSpPr>
+          <p:cNvPr id="5" name="Rounded Rectangle 4"/>
+          <p:cNvSpPr/>
+          <p:nvPr/>
+        </p:nvSpPr>
+        <p:spPr>
+          <a:xfrm>
+            <a:off x="8442960" y="1417320"/>
+            <a:ext cx="3200400" cy="4782680"/>
+          </a:xfrm>
+          <a:prstGeom prst="roundRect">
+            <a:avLst>
+              <a:gd name="adj" fmla="val 2476"/>
+            </a:avLst>
+          </a:prstGeom>
+          <a:solidFill>
+            <a:srgbClr val="EFF3FA"/>
+          </a:solidFill>
+          <a:ln>
+            <a:noFill/>
+          </a:ln>
+        </p:spPr>
+        <p:style>
+          <a:lnRef idx="1">
+            <a:schemeClr val="accent1"/>
+          </a:lnRef>
+          <a:fillRef idx="3">
+            <a:schemeClr val="accent1"/>
+          </a:fillRef>
+          <a:effectRef idx="2">
+            <a:schemeClr val="accent1"/>
+          </a:effectRef>
+          <a:fontRef idx="minor">
+            <a:schemeClr val="lt1"/>
+          </a:fontRef>
+        </p:style>
+        <p:txBody>
+          <a:bodyPr rtlCol="0" anchor="ctr"/>
+          <a:lstStyle/>
+          <a:p>
+            <a:pPr algn="ctr"/>
+          </a:p>
+        </p:txBody>
+      </p:sp>
+      <p:sp>
+        <p:nvSpPr>
+          <p:cNvPr id="6" name="TextBox 5"/>
+          <p:cNvSpPr txBox="1"/>
+          <p:nvPr/>
+        </p:nvSpPr>
+        <p:spPr>
+          <a:xfrm>
+            <a:off x="8671560" y="1618488"/>
+            <a:ext cx="2743200" cy="4380344"/>
+          </a:xfrm>
+          <a:prstGeom prst="rect">
+            <a:avLst/>
+          </a:prstGeom>
+          <a:noFill/>
+        </p:spPr>
+        <p:txBody>
+          <a:bodyPr wrap="square">
+            <a:spAutoFit/>
+          </a:bodyPr>
+          <a:lstStyle/>
+          <a:p>
+            <a:r>
+              <a:rPr sz="1300" b="1">
+                <a:solidFill>
+                  <a:srgbClr val="1E2761"/>
+                </a:solidFill>
+                <a:latin typeface="Calibri"/>
+              </a:rPr>
+              <a:t>How to read it</a:t>
+            </a:r>
+          </a:p>
+          <a:p>
+            <a:pPr marL="228600" indent="-228600">
+              <a:spcBef>
+                <a:spcPts val="1000"/>
+              </a:spcBef>
+              <a:buFont typeface="Arial"/>
+              <a:buChar char="•"/>
+            </a:pPr>
+            <a:r>
+              <a:rPr sz="1150">
+                <a:solidFill>
+                  <a:srgbClr val="1F2937"/>
+                </a:solidFill>
+                <a:latin typeface="Calibri"/>
+              </a:rPr>
+              <a:t>Each point is one NJ tract. Dashed lines mark CV = 0.30 (ACS reference) and the NJ 75th percentile of income allocation (~0.46).</a:t>
+            </a:r>
+          </a:p>
+          <a:p>
+            <a:pPr marL="228600" indent="-228600">
+              <a:spcBef>
+                <a:spcPts val="1000"/>
+              </a:spcBef>
+              <a:buFont typeface="Arial"/>
+              <a:buChar char="•"/>
+            </a:pPr>
+            <a:r>
+              <a:rPr sz="1150">
+                <a:solidFill>
+                  <a:srgbClr val="1F2937"/>
+                </a:solidFill>
+                <a:latin typeface="Calibri"/>
+              </a:rPr>
+              <a:t>Gold = low CV / high allocation (n=481, 22.8% of classified tracts). That's the blind spot: published error bars look fine, but imputation does not.</a:t>
+            </a:r>
+          </a:p>
+          <a:p>
+            <a:pPr marL="228600" indent="-228600">
+              <a:spcBef>
+                <a:spcPts val="1000"/>
+              </a:spcBef>
+              <a:buFont typeface="Arial"/>
+              <a:buChar char="•"/>
+            </a:pPr>
+            <a:r>
+              <a:rPr sz="1150">
+                <a:solidFill>
+                  <a:srgbClr val="1F2937"/>
+                </a:solidFill>
+                <a:latin typeface="Calibri"/>
+              </a:rPr>
+              <a:t>Why it matters: a score built on MOEs alone would call these tracts reliable. Matrix stays the headline; weights not locked (equal-weight vs worst-component agree on ~85% of top-risk-quartile membership).</a:t>
+            </a:r>
+          </a:p>
+        </p:txBody>
+      </p:sp>
+      <p:pic>
+        <p:nvPicPr>
+          <p:cNvPr id="7" name="Picture 6" descr="eda06-income-blind-spot.png"/>
+          <p:cNvPicPr>
+            <a:picLocks noChangeAspect="1"/>
+          </p:cNvPicPr>
+          <p:nvPr/>
+        </p:nvPicPr>
+        <p:blipFill>
+          <a:blip r:embed="rId4"/>
+          <a:stretch>
+            <a:fillRect/>
+          </a:stretch>
+        </p:blipFill>
+        <p:spPr>
+          <a:xfrm>
+            <a:off x="701296" y="1417320"/>
+            <a:ext cx="7314687" cy="4782680"/>
+          </a:xfrm>
+          <a:prstGeom prst="rect">
+            <a:avLst/>
+          </a:prstGeom>
+        </p:spPr>
+      </p:pic>
+    </p:spTree>
+  </p:cSld>
+  <p:clrMapOvr>
+    <a:masterClrMapping/>
+  </p:clrMapOvr>
+</p:sld>
+</file>
+
+<file path=ppt/slides/slide11.xml><?xml version="1.0" encoding="utf-8"?>
+<p:sld xmlns:a="http://schemas.openxmlformats.org/drawingml/2006/main" xmlns:p="http://schemas.openxmlformats.org/presentationml/2006/main" xmlns:r="http://schemas.openxmlformats.org/officeDocument/2006/relationships">
+  <p:cSld>
+    <p:spTree>
+      <p:nvGrpSpPr>
+        <p:cNvPr id="1" name=""/>
+        <p:cNvGrpSpPr/>
+        <p:nvPr/>
+      </p:nvGrpSpPr>
+      <p:grpSpPr/>
+      <p:sp>
+        <p:nvSpPr>
+          <p:cNvPr id="2" name="TextBox 1"/>
+          <p:cNvSpPr txBox="1"/>
+          <p:nvPr/>
+        </p:nvSpPr>
+        <p:spPr>
+          <a:xfrm>
+            <a:off x="548640" y="384048"/>
+            <a:ext cx="11064240" cy="292608"/>
+          </a:xfrm>
+          <a:prstGeom prst="rect">
+            <a:avLst/>
+          </a:prstGeom>
+          <a:noFill/>
+        </p:spPr>
+        <p:txBody>
+          <a:bodyPr wrap="square">
+            <a:spAutoFit/>
+          </a:bodyPr>
+          <a:lstStyle/>
+          <a:p>
+            <a:r>
+              <a:rPr sz="1050" b="1">
+                <a:solidFill>
+                  <a:srgbClr val="5A6B85"/>
+                </a:solidFill>
+                <a:latin typeface="Calibri"/>
+              </a:rPr>
+              <a:t>BACKUP  ·  CV DRIVER MODEL (EDA 07)</a:t>
+            </a:r>
+          </a:p>
+        </p:txBody>
+      </p:sp>
+      <p:sp>
+        <p:nvSpPr>
+          <p:cNvPr id="3" name="TextBox 2"/>
+          <p:cNvSpPr txBox="1"/>
+          <p:nvPr/>
+        </p:nvSpPr>
+        <p:spPr>
+          <a:xfrm>
+            <a:off x="548640" y="658368"/>
+            <a:ext cx="11064240" cy="566928"/>
+          </a:xfrm>
+          <a:prstGeom prst="rect">
+            <a:avLst/>
+          </a:prstGeom>
+          <a:noFill/>
+        </p:spPr>
+        <p:txBody>
+          <a:bodyPr wrap="square">
+            <a:spAutoFit/>
+          </a:bodyPr>
+          <a:lstStyle/>
+          <a:p>
+            <a:r>
+              <a:rPr sz="2400" b="0">
+                <a:solidFill>
+                  <a:srgbClr val="1E2761"/>
+                </a:solidFill>
+                <a:latin typeface="Calibri Light"/>
+              </a:rPr>
+              <a:t>Score the estimate, not the place</a:t>
+            </a:r>
+          </a:p>
+        </p:txBody>
+      </p:sp>
+      <p:sp>
+        <p:nvSpPr>
+          <p:cNvPr id="5" name="Rounded Rectangle 4"/>
+          <p:cNvSpPr/>
+          <p:nvPr/>
+        </p:nvSpPr>
+        <p:spPr>
+          <a:xfrm>
+            <a:off x="8442960" y="1417320"/>
+            <a:ext cx="3200400" cy="4782680"/>
+          </a:xfrm>
+          <a:prstGeom prst="roundRect">
+            <a:avLst>
+              <a:gd name="adj" fmla="val 2476"/>
+            </a:avLst>
+          </a:prstGeom>
+          <a:solidFill>
+            <a:srgbClr val="EFF3FA"/>
+          </a:solidFill>
+          <a:ln>
+            <a:noFill/>
+          </a:ln>
+        </p:spPr>
+        <p:style>
+          <a:lnRef idx="1">
+            <a:schemeClr val="accent1"/>
+          </a:lnRef>
+          <a:fillRef idx="3">
+            <a:schemeClr val="accent1"/>
+          </a:fillRef>
+          <a:effectRef idx="2">
+            <a:schemeClr val="accent1"/>
+          </a:effectRef>
+          <a:fontRef idx="minor">
+            <a:schemeClr val="lt1"/>
+          </a:fontRef>
+        </p:style>
+        <p:txBody>
+          <a:bodyPr rtlCol="0" anchor="ctr"/>
+          <a:lstStyle/>
+          <a:p>
+            <a:pPr algn="ctr"/>
+          </a:p>
+        </p:txBody>
+      </p:sp>
+      <p:sp>
+        <p:nvSpPr>
+          <p:cNvPr id="6" name="TextBox 5"/>
+          <p:cNvSpPr txBox="1"/>
+          <p:nvPr/>
+        </p:nvSpPr>
+        <p:spPr>
+          <a:xfrm>
+            <a:off x="8671560" y="1618488"/>
+            <a:ext cx="2743200" cy="4380344"/>
+          </a:xfrm>
+          <a:prstGeom prst="rect">
+            <a:avLst/>
+          </a:prstGeom>
+          <a:noFill/>
+        </p:spPr>
+        <p:txBody>
+          <a:bodyPr wrap="square">
+            <a:spAutoFit/>
+          </a:bodyPr>
+          <a:lstStyle/>
+          <a:p>
+            <a:r>
+              <a:rPr sz="1300" b="1">
+                <a:solidFill>
+                  <a:srgbClr val="1E2761"/>
+                </a:solidFill>
+                <a:latin typeface="Calibri"/>
+              </a:rPr>
+              <a:t>How to read it</a:t>
+            </a:r>
+          </a:p>
+          <a:p>
+            <a:pPr marL="228600" indent="-228600">
+              <a:spcBef>
+                <a:spcPts val="1000"/>
+              </a:spcBef>
+              <a:buFont typeface="Arial"/>
+              <a:buChar char="•"/>
+            </a:pPr>
+            <a:r>
+              <a:rPr sz="1150">
+                <a:solidFill>
+                  <a:srgbClr val="1F2937"/>
+                </a:solidFill>
+                <a:latin typeface="Calibri"/>
+              </a:rPr>
+              <a:t>Each bar is one model's R² (the share of CV variance it explains), run in sequence on n≈24,947 rows.</a:t>
+            </a:r>
+          </a:p>
+          <a:p>
+            <a:pPr marL="228600" indent="-228600">
+              <a:spcBef>
+                <a:spcPts val="1000"/>
+              </a:spcBef>
+              <a:buFont typeface="Arial"/>
+              <a:buChar char="•"/>
+            </a:pPr>
+            <a:r>
+              <a:rPr sz="1150">
+                <a:solidFill>
+                  <a:srgbClr val="1F2937"/>
+                </a:solidFill>
+                <a:latin typeface="Calibri"/>
+              </a:rPr>
+              <a:t>Population alone explains almost nothing (R²≈0.005). Swapping in estimate size jumps to R²≈0.666, by far the biggest gain.</a:t>
+            </a:r>
+          </a:p>
+          <a:p>
+            <a:pPr marL="228600" indent="-228600">
+              <a:spcBef>
+                <a:spcPts val="1000"/>
+              </a:spcBef>
+              <a:buFont typeface="Arial"/>
+              <a:buChar char="•"/>
+            </a:pPr>
+            <a:r>
+              <a:rPr sz="1150">
+                <a:solidFill>
+                  <a:srgbClr val="1F2937"/>
+                </a:solidFill>
+                <a:latin typeface="Calibri"/>
+              </a:rPr>
+              <a:t>Adding geography level and variable group reaches R²≈0.706. Adding interactions reaches R²≈0.726.</a:t>
+            </a:r>
+          </a:p>
+          <a:p>
+            <a:pPr marL="228600" indent="-228600">
+              <a:spcBef>
+                <a:spcPts val="1000"/>
+              </a:spcBef>
+              <a:buFont typeface="Arial"/>
+              <a:buChar char="•"/>
+            </a:pPr>
+            <a:r>
+              <a:rPr sz="1150">
+                <a:solidFill>
+                  <a:srgbClr val="1F2937"/>
+                </a:solidFill>
+                <a:latin typeface="Calibri"/>
+              </a:rPr>
+              <a:t>Caveat: income medians are weakly size-explained (R²≈0.01), so residual flags work better for count variables than for income.</a:t>
+            </a:r>
+          </a:p>
+        </p:txBody>
+      </p:sp>
+      <p:pic>
+        <p:nvPicPr>
+          <p:cNvPr id="7" name="Picture 6" descr="eda07-r2-waterfall.png"/>
+          <p:cNvPicPr>
+            <a:picLocks noChangeAspect="1"/>
+          </p:cNvPicPr>
+          <p:nvPr/>
+        </p:nvPicPr>
+        <p:blipFill>
+          <a:blip r:embed="rId4"/>
+          <a:stretch>
+            <a:fillRect/>
+          </a:stretch>
+        </p:blipFill>
+        <p:spPr>
+          <a:xfrm>
+            <a:off x="771630" y="1417320"/>
+            <a:ext cx="7174020" cy="4782680"/>
+          </a:xfrm>
+          <a:prstGeom prst="rect">
+            <a:avLst/>
+          </a:prstGeom>
+        </p:spPr>
+      </p:pic>
+    </p:spTree>
+  </p:cSld>
+  <p:clrMapOvr>
+    <a:masterClrMapping/>
+  </p:clrMapOvr>
+</p:sld>
+</file>
+
 <file path=ppt/slides/slide2.xml><?xml version="1.0" encoding="utf-8"?>
 <p:sld xmlns:a="http://schemas.openxmlformats.org/drawingml/2006/main" xmlns:r="http://schemas.openxmlformats.org/officeDocument/2006/relationships" xmlns:p="http://schemas.openxmlformats.org/presentationml/2006/main">
   <p:cSld name="Slide 2">

</xml_diff>